<commit_message>
Implement code changes to enhance functionality and improve performance
</commit_message>
<xml_diff>
--- a/Temp-Note-Share.pptx
+++ b/Temp-Note-Share.pptx
@@ -247,7 +247,7 @@
             <a:fld id="{5D7D9F59-1E10-4A9B-A1B9-2BAC453C0211}" type="datetimeFigureOut">
               <a:rPr lang="en-US" smtClean="0"/>
               <a:pPr/>
-              <a:t>3/18/25</a:t>
+              <a:t>3/19/25</a:t>
             </a:fld>
             <a:endParaRPr lang="en-US"/>
           </a:p>
@@ -415,7 +415,7 @@
             <a:fld id="{D37E6848-630C-4143-931A-3482CD985CE7}" type="datetimeFigureOut">
               <a:rPr lang="en-US" smtClean="0"/>
               <a:pPr/>
-              <a:t>3/18/25</a:t>
+              <a:t>3/19/25</a:t>
             </a:fld>
             <a:endParaRPr lang="en-US"/>
           </a:p>
@@ -911,7 +911,7 @@
             <a:fld id="{2FFA4D39-3DF9-45F0-B12A-A60F2B84AF00}" type="datetime1">
               <a:rPr lang="en-US" smtClean="0"/>
               <a:pPr/>
-              <a:t>3/18/25</a:t>
+              <a:t>3/19/25</a:t>
             </a:fld>
             <a:endParaRPr lang="en-US"/>
           </a:p>
@@ -1124,7 +1124,7 @@
             <a:fld id="{46BA10A5-7694-4E6D-B9EB-5FED3A264B2B}" type="datetime1">
               <a:rPr lang="en-US" smtClean="0"/>
               <a:pPr/>
-              <a:t>3/18/25</a:t>
+              <a:t>3/19/25</a:t>
             </a:fld>
             <a:endParaRPr lang="en-US"/>
           </a:p>
@@ -1385,7 +1385,7 @@
             <a:fld id="{F9E15FEA-70C5-4284-AE7E-C5E02B60CA1B}" type="datetime1">
               <a:rPr lang="en-US" smtClean="0"/>
               <a:pPr/>
-              <a:t>3/18/25</a:t>
+              <a:t>3/19/25</a:t>
             </a:fld>
             <a:endParaRPr lang="en-US"/>
           </a:p>
@@ -1564,7 +1564,7 @@
             <a:fld id="{FB80A95E-1C47-4CEF-BFBB-0974FDB304DB}" type="datetime1">
               <a:rPr lang="en-US" smtClean="0"/>
               <a:pPr/>
-              <a:t>3/18/25</a:t>
+              <a:t>3/19/25</a:t>
             </a:fld>
             <a:endParaRPr lang="en-US"/>
           </a:p>
@@ -1912,7 +1912,7 @@
             <a:fld id="{CA88B2C4-D439-45A3-A117-51F3E01B60C3}" type="datetime1">
               <a:rPr lang="en-US" smtClean="0"/>
               <a:pPr/>
-              <a:t>3/18/25</a:t>
+              <a:t>3/19/25</a:t>
             </a:fld>
             <a:endParaRPr lang="en-US"/>
           </a:p>
@@ -2192,7 +2192,7 @@
             <a:fld id="{D7067F6E-A66B-4381-8A2C-3486C09D598B}" type="datetime1">
               <a:rPr lang="en-US" smtClean="0"/>
               <a:pPr/>
-              <a:t>3/18/25</a:t>
+              <a:t>3/19/25</a:t>
             </a:fld>
             <a:endParaRPr lang="en-US"/>
           </a:p>
@@ -2576,7 +2576,7 @@
             <a:fld id="{F896E20F-C7C1-4D22-8980-41122AA8A602}" type="datetime1">
               <a:rPr lang="en-US" smtClean="0"/>
               <a:pPr/>
-              <a:t>3/18/25</a:t>
+              <a:t>3/19/25</a:t>
             </a:fld>
             <a:endParaRPr lang="en-US"/>
           </a:p>
@@ -2699,7 +2699,7 @@
             <a:fld id="{FCB8222F-A0B4-4627-BA7D-1684A17AC69B}" type="datetime1">
               <a:rPr lang="en-US" smtClean="0"/>
               <a:pPr/>
-              <a:t>3/18/25</a:t>
+              <a:t>3/19/25</a:t>
             </a:fld>
             <a:endParaRPr lang="en-US"/>
           </a:p>
@@ -2875,7 +2875,7 @@
             <a:fld id="{2F57C41A-BDE4-4D8F-A183-1217B30E28B4}" type="datetime1">
               <a:rPr lang="en-US" smtClean="0"/>
               <a:pPr/>
-              <a:t>3/18/25</a:t>
+              <a:t>3/19/25</a:t>
             </a:fld>
             <a:endParaRPr lang="en-US"/>
           </a:p>
@@ -3234,7 +3234,7 @@
             <a:fld id="{0C31206F-3307-4F0F-A434-2A5B37659217}" type="datetime1">
               <a:rPr lang="en-US" smtClean="0"/>
               <a:pPr/>
-              <a:t>3/18/25</a:t>
+              <a:t>3/19/25</a:t>
             </a:fld>
             <a:endParaRPr lang="en-US"/>
           </a:p>
@@ -3621,7 +3621,7 @@
             <a:fld id="{27F0B680-DFE7-47E7-8C10-791358E93EC8}" type="datetime1">
               <a:rPr lang="en-US" smtClean="0"/>
               <a:pPr/>
-              <a:t>3/18/25</a:t>
+              <a:t>3/19/25</a:t>
             </a:fld>
             <a:endParaRPr lang="en-US"/>
           </a:p>
@@ -3913,7 +3913,7 @@
             <a:fld id="{71EE931B-43B2-469F-93B9-3C56D1192037}" type="datetime1">
               <a:rPr lang="en-US" smtClean="0"/>
               <a:pPr/>
-              <a:t>3/18/25</a:t>
+              <a:t>3/19/25</a:t>
             </a:fld>
             <a:endParaRPr lang="en-US"/>
           </a:p>
@@ -8154,8 +8154,9 @@
             </a:r>
           </a:p>
           <a:p>
-            <a:pPr>
-              <a:buNone/>
+            <a:pPr rtl="0" fontAlgn="base">
+              <a:buFont typeface="Arial" panose="020B0604020202020204" pitchFamily="34" charset="0"/>
+              <a:buChar char="•"/>
             </a:pPr>
             <a:r>
               <a:rPr lang="en-IN" sz="1800" b="1" i="0" u="none" strike="noStrike" dirty="0">

</xml_diff>